<commit_message>
Aggiunge slide uscita per banda e plot ΔV(f) vs frequenza
Co-Authored-By: Claude Sonnet 4.6 <noreply@anthropic.com>
</commit_message>
<xml_diff>
--- a/bolometro_simulato.pptx
+++ b/bolometro_simulato.pptx
@@ -15,6 +15,7 @@
     <p:sldId id="263" r:id="rId14"/>
     <p:sldId id="264" r:id="rId15"/>
     <p:sldId id="265" r:id="rId16"/>
+    <p:sldId id="268" r:id="rId19"/>
     <p:sldId id="266" r:id="rId17"/>
     <p:sldId id="267" r:id="rId18"/>
   </p:sldIdLst>
@@ -6558,6 +6559,279 @@
           </a:p>
         </p:txBody>
       </p:sp>
+    </p:spTree>
+  </p:cSld>
+  <p:clrMapOvr>
+    <a:masterClrMapping/>
+  </p:clrMapOvr>
+</p:sld>
+</file>
+
+<file path=ppt/slides/slide13.xml><?xml version="1.0" encoding="utf-8"?>
+<p:sld xmlns:a="http://schemas.openxmlformats.org/drawingml/2006/main" xmlns:p="http://schemas.openxmlformats.org/presentationml/2006/main" xmlns:r="http://schemas.openxmlformats.org/officeDocument/2006/relationships">
+  <p:cSld>
+    <p:spTree>
+      <p:nvGrpSpPr>
+        <p:cNvPr id="1" name=""/>
+        <p:cNvGrpSpPr/>
+        <p:nvPr/>
+      </p:nvGrpSpPr>
+      <p:grpSpPr/>
+      <p:sp>
+        <p:nvSpPr>
+          <p:cNvPr id="2" name="Rectangle 1"/>
+          <p:cNvSpPr/>
+          <p:nvPr/>
+        </p:nvSpPr>
+        <p:spPr>
+          <a:xfrm>
+            <a:off x="0" y="0"/>
+            <a:ext cx="9144000" cy="5143500"/>
+          </a:xfrm>
+          <a:prstGeom prst="rect">
+            <a:avLst/>
+          </a:prstGeom>
+          <a:solidFill>
+            <a:srgbClr val="0D2137"/>
+          </a:solidFill>
+          <a:ln>
+            <a:noFill/>
+          </a:ln>
+        </p:spPr>
+        <p:style>
+          <a:lnRef idx="1">
+            <a:schemeClr val="accent1"/>
+          </a:lnRef>
+          <a:fillRef idx="3">
+            <a:schemeClr val="accent1"/>
+          </a:fillRef>
+          <a:effectRef idx="2">
+            <a:schemeClr val="accent1"/>
+          </a:effectRef>
+          <a:fontRef idx="minor">
+            <a:schemeClr val="lt1"/>
+          </a:fontRef>
+        </p:style>
+        <p:txBody>
+          <a:bodyPr rtlCol="0" anchor="ctr"/>
+          <a:lstStyle/>
+          <a:p>
+            <a:pPr algn="ctr"/>
+          </a:p>
+        </p:txBody>
+      </p:sp>
+      <p:sp>
+        <p:nvSpPr>
+          <p:cNvPr id="3" name="Rectangle 2"/>
+          <p:cNvSpPr/>
+          <p:nvPr/>
+        </p:nvSpPr>
+        <p:spPr>
+          <a:xfrm>
+            <a:off x="0" y="0"/>
+            <a:ext cx="9144000" cy="685800"/>
+          </a:xfrm>
+          <a:prstGeom prst="rect">
+            <a:avLst/>
+          </a:prstGeom>
+          <a:solidFill>
+            <a:srgbClr val="091929"/>
+          </a:solidFill>
+          <a:ln>
+            <a:noFill/>
+          </a:ln>
+        </p:spPr>
+        <p:style>
+          <a:lnRef idx="1">
+            <a:schemeClr val="accent1"/>
+          </a:lnRef>
+          <a:fillRef idx="3">
+            <a:schemeClr val="accent1"/>
+          </a:fillRef>
+          <a:effectRef idx="2">
+            <a:schemeClr val="accent1"/>
+          </a:effectRef>
+          <a:fontRef idx="minor">
+            <a:schemeClr val="lt1"/>
+          </a:fontRef>
+        </p:style>
+        <p:txBody>
+          <a:bodyPr rtlCol="0" anchor="ctr"/>
+          <a:lstStyle/>
+          <a:p>
+            <a:pPr algn="ctr"/>
+          </a:p>
+        </p:txBody>
+      </p:sp>
+      <p:sp>
+        <p:nvSpPr>
+          <p:cNvPr id="4" name="Rectangle 3"/>
+          <p:cNvSpPr/>
+          <p:nvPr/>
+        </p:nvSpPr>
+        <p:spPr>
+          <a:xfrm>
+            <a:off x="0" y="685800"/>
+            <a:ext cx="9144000" cy="41148"/>
+          </a:xfrm>
+          <a:prstGeom prst="rect">
+            <a:avLst/>
+          </a:prstGeom>
+          <a:solidFill>
+            <a:srgbClr val="00B4D8"/>
+          </a:solidFill>
+          <a:ln>
+            <a:noFill/>
+          </a:ln>
+        </p:spPr>
+        <p:style>
+          <a:lnRef idx="1">
+            <a:schemeClr val="accent1"/>
+          </a:lnRef>
+          <a:fillRef idx="3">
+            <a:schemeClr val="accent1"/>
+          </a:fillRef>
+          <a:effectRef idx="2">
+            <a:schemeClr val="accent1"/>
+          </a:effectRef>
+          <a:fontRef idx="minor">
+            <a:schemeClr val="lt1"/>
+          </a:fontRef>
+        </p:style>
+        <p:txBody>
+          <a:bodyPr rtlCol="0" anchor="ctr"/>
+          <a:lstStyle/>
+          <a:p>
+            <a:pPr algn="ctr"/>
+          </a:p>
+        </p:txBody>
+      </p:sp>
+      <p:sp>
+        <p:nvSpPr>
+          <p:cNvPr id="5" name="TextBox 4"/>
+          <p:cNvSpPr txBox="1"/>
+          <p:nvPr/>
+        </p:nvSpPr>
+        <p:spPr>
+          <a:xfrm>
+            <a:off x="320040" y="91440"/>
+            <a:ext cx="8503920" cy="594360"/>
+          </a:xfrm>
+          <a:prstGeom prst="rect">
+            <a:avLst/>
+          </a:prstGeom>
+          <a:noFill/>
+        </p:spPr>
+        <p:txBody>
+          <a:bodyPr wrap="square">
+            <a:spAutoFit/>
+          </a:bodyPr>
+          <a:lstStyle/>
+          <a:p>
+            <a:pPr algn="l"/>
+            <a:r>
+              <a:rPr sz="2400" b="1" i="0">
+                <a:solidFill>
+                  <a:srgbClr val="FFFFFF"/>
+                </a:solidFill>
+              </a:rPr>
+              <a:t>RISULTATI — USCITA PER BANDA DI FREQUENZA</a:t>
+            </a:r>
+          </a:p>
+        </p:txBody>
+      </p:sp>
+      <p:sp>
+        <p:nvSpPr>
+          <p:cNvPr id="6" name="TextBox 5"/>
+          <p:cNvSpPr txBox="1"/>
+          <p:nvPr/>
+        </p:nvSpPr>
+        <p:spPr>
+          <a:xfrm>
+            <a:off x="320040" y="713232"/>
+            <a:ext cx="8503920" cy="320040"/>
+          </a:xfrm>
+          <a:prstGeom prst="rect">
+            <a:avLst/>
+          </a:prstGeom>
+          <a:noFill/>
+        </p:spPr>
+        <p:txBody>
+          <a:bodyPr wrap="square">
+            <a:spAutoFit/>
+          </a:bodyPr>
+          <a:lstStyle/>
+          <a:p>
+            <a:pPr algn="l"/>
+            <a:r>
+              <a:rPr sz="1200" b="0" i="0">
+                <a:solidFill>
+                  <a:srgbClr val="00B4D8"/>
+                </a:solidFill>
+              </a:rPr>
+              <a:t>ΔV(f) = forward_model(B(f,T)·A(f))  — colorato per regime operativo</a:t>
+            </a:r>
+          </a:p>
+        </p:txBody>
+      </p:sp>
+      <p:sp>
+        <p:nvSpPr>
+          <p:cNvPr id="7" name="TextBox 6"/>
+          <p:cNvSpPr txBox="1"/>
+          <p:nvPr/>
+        </p:nvSpPr>
+        <p:spPr>
+          <a:xfrm>
+            <a:off x="274320" y="749808"/>
+            <a:ext cx="8595360" cy="320040"/>
+          </a:xfrm>
+          <a:prstGeom prst="rect">
+            <a:avLst/>
+          </a:prstGeom>
+          <a:noFill/>
+        </p:spPr>
+        <p:txBody>
+          <a:bodyPr wrap="square">
+            <a:spAutoFit/>
+          </a:bodyPr>
+          <a:lstStyle/>
+          <a:p>
+            <a:pPr algn="l"/>
+            <a:r>
+              <a:rPr sz="1100" b="0" i="0">
+                <a:solidFill>
+                  <a:srgbClr val="B0C8D8"/>
+                </a:solidFill>
+              </a:rPr>
+              <a:t>Segnale ideale (sx) e reale con rumore (dx) in funzione della frequenza. Verde = ricostruibile · Rosso = rumore dom. · Arancione = saturato.</a:t>
+            </a:r>
+          </a:p>
+        </p:txBody>
+      </p:sp>
+      <p:pic>
+        <p:nvPicPr>
+          <p:cNvPr id="8" name="Picture 7" descr="blocco3_uscita_banda.png"/>
+          <p:cNvPicPr>
+            <a:picLocks noChangeAspect="1"/>
+          </p:cNvPicPr>
+          <p:nvPr/>
+        </p:nvPicPr>
+        <p:blipFill>
+          <a:blip r:embed="rId2"/>
+          <a:stretch>
+            <a:fillRect/>
+          </a:stretch>
+        </p:blipFill>
+        <p:spPr>
+          <a:xfrm>
+            <a:off x="274320" y="1097280"/>
+            <a:ext cx="8595360" cy="3840480"/>
+          </a:xfrm>
+          <a:prstGeom prst="rect">
+            <a:avLst/>
+          </a:prstGeom>
+        </p:spPr>
+      </p:pic>
     </p:spTree>
   </p:cSld>
   <p:clrMapOvr>

</xml_diff>